<commit_message>
Update motivation to latest statistics
</commit_message>
<xml_diff>
--- a/Memory_Safety_Rust.pptx
+++ b/Memory_Safety_Rust.pptx
@@ -5,7 +5,7 @@
     <p:sldMasterId id="2147483660" r:id="rId1"/>
   </p:sldMasterIdLst>
   <p:notesMasterIdLst>
-    <p:notesMasterId r:id="rId18"/>
+    <p:notesMasterId r:id="rId19"/>
   </p:notesMasterIdLst>
   <p:sldIdLst>
     <p:sldId id="256" r:id="rId2"/>
@@ -24,6 +24,7 @@
     <p:sldId id="275" r:id="rId15"/>
     <p:sldId id="274" r:id="rId16"/>
     <p:sldId id="259" r:id="rId17"/>
+    <p:sldId id="276" r:id="rId18"/>
   </p:sldIdLst>
   <p:sldSz cx="12192000" cy="6858000"/>
   <p:notesSz cx="6858000" cy="9144000"/>
@@ -161,9 +162,13 @@
         <p14:section name="Sources" id="{3213A62E-4387-4F50-8DCC-554714B34329}">
           <p14:sldIdLst>
             <p14:sldId id="259"/>
+            <p14:sldId id="276"/>
           </p14:sldIdLst>
         </p14:section>
       </p14:sectionLst>
+    </p:ext>
+    <p:ext uri="{EFAFB233-063F-42B5-8137-9DF3F51BA10A}">
+      <p15:sldGuideLst xmlns:p15="http://schemas.microsoft.com/office/powerpoint/2012/main"/>
     </p:ext>
   </p:extLst>
 </p:presentation>
@@ -251,7 +256,7 @@
           <a:p>
             <a:fld id="{67D40B27-32DC-4257-8536-E60282C13369}" type="datetimeFigureOut">
               <a:rPr lang="en-US" smtClean="0"/>
-              <a:t>12/8/2025</a:t>
+              <a:t>5/14/2026</a:t>
             </a:fld>
             <a:endParaRPr lang="en-US"/>
           </a:p>
@@ -1020,13 +1025,13 @@
           <p:nvPr userDrawn="1"/>
         </p:nvPicPr>
         <p:blipFill>
-          <a:blip r:embed="rId2" cstate="print">
+          <a:blip cstate="print">
             <a:extLst>
               <a:ext uri="{28A0092B-C50C-407E-A947-70E740481C1C}">
                 <a14:useLocalDpi xmlns:a14="http://schemas.microsoft.com/office/drawing/2010/main"/>
               </a:ext>
               <a:ext uri="{96DAC541-7B7A-43D3-8B79-37D633B846F1}">
-                <asvg:svgBlip xmlns:asvg="http://schemas.microsoft.com/office/drawing/2016/SVG/main" r:embed="rId3"/>
+                <asvg:svgBlip xmlns:asvg="http://schemas.microsoft.com/office/drawing/2016/SVG/main" r:embed="rId2"/>
               </a:ext>
             </a:extLst>
           </a:blip>
@@ -1058,7 +1063,7 @@
           <p:nvPr userDrawn="1"/>
         </p:nvPicPr>
         <p:blipFill>
-          <a:blip r:embed="rId4"/>
+          <a:blip r:embed="rId3"/>
           <a:stretch>
             <a:fillRect/>
           </a:stretch>
@@ -1542,13 +1547,13 @@
           <p:nvPr userDrawn="1"/>
         </p:nvPicPr>
         <p:blipFill>
-          <a:blip r:embed="rId6" cstate="print">
+          <a:blip cstate="print">
             <a:extLst>
               <a:ext uri="{28A0092B-C50C-407E-A947-70E740481C1C}">
                 <a14:useLocalDpi xmlns:a14="http://schemas.microsoft.com/office/drawing/2010/main"/>
               </a:ext>
               <a:ext uri="{96DAC541-7B7A-43D3-8B79-37D633B846F1}">
-                <asvg:svgBlip xmlns:asvg="http://schemas.microsoft.com/office/drawing/2016/SVG/main" r:embed="rId7"/>
+                <asvg:svgBlip xmlns:asvg="http://schemas.microsoft.com/office/drawing/2016/SVG/main" r:embed="rId6"/>
               </a:ext>
             </a:extLst>
           </a:blip>
@@ -1580,7 +1585,7 @@
           <p:nvPr userDrawn="1"/>
         </p:nvPicPr>
         <p:blipFill>
-          <a:blip r:embed="rId8"/>
+          <a:blip r:embed="rId7"/>
           <a:stretch>
             <a:fillRect/>
           </a:stretch>
@@ -1610,7 +1615,7 @@
           <p:nvPr userDrawn="1"/>
         </p:nvPicPr>
         <p:blipFill>
-          <a:blip r:embed="rId9">
+          <a:blip r:embed="rId8">
             <a:alphaModFix amt="3000"/>
             <a:extLst>
               <a:ext uri="{28A0092B-C50C-407E-A947-70E740481C1C}">
@@ -6588,10 +6593,10 @@
           <p:nvPr/>
         </p:nvPicPr>
         <p:blipFill>
-          <a:blip r:embed="rId3">
+          <a:blip>
             <a:extLst>
               <a:ext uri="{96DAC541-7B7A-43D3-8B79-37D633B846F1}">
-                <asvg:svgBlip xmlns:asvg="http://schemas.microsoft.com/office/drawing/2016/SVG/main" r:embed="rId4"/>
+                <asvg:svgBlip xmlns:asvg="http://schemas.microsoft.com/office/drawing/2016/SVG/main" r:embed="rId3"/>
               </a:ext>
             </a:extLst>
           </a:blip>
@@ -7014,10 +7019,10 @@
           <p:nvPr/>
         </p:nvPicPr>
         <p:blipFill>
-          <a:blip r:embed="rId2">
+          <a:blip>
             <a:extLst>
               <a:ext uri="{96DAC541-7B7A-43D3-8B79-37D633B846F1}">
-                <asvg:svgBlip xmlns:asvg="http://schemas.microsoft.com/office/drawing/2016/SVG/main" r:embed="rId3"/>
+                <asvg:svgBlip xmlns:asvg="http://schemas.microsoft.com/office/drawing/2016/SVG/main" r:embed="rId2"/>
               </a:ext>
             </a:extLst>
           </a:blip>
@@ -7050,10 +7055,10 @@
           <p:nvPr/>
         </p:nvPicPr>
         <p:blipFill>
-          <a:blip r:embed="rId4">
+          <a:blip>
             <a:extLst>
               <a:ext uri="{96DAC541-7B7A-43D3-8B79-37D633B846F1}">
-                <asvg:svgBlip xmlns:asvg="http://schemas.microsoft.com/office/drawing/2016/SVG/main" r:embed="rId5"/>
+                <asvg:svgBlip xmlns:asvg="http://schemas.microsoft.com/office/drawing/2016/SVG/main" r:embed="rId3"/>
               </a:ext>
             </a:extLst>
           </a:blip>
@@ -7086,10 +7091,10 @@
           <p:nvPr/>
         </p:nvPicPr>
         <p:blipFill>
-          <a:blip r:embed="rId6">
+          <a:blip>
             <a:extLst>
               <a:ext uri="{96DAC541-7B7A-43D3-8B79-37D633B846F1}">
-                <asvg:svgBlip xmlns:asvg="http://schemas.microsoft.com/office/drawing/2016/SVG/main" r:embed="rId7"/>
+                <asvg:svgBlip xmlns:asvg="http://schemas.microsoft.com/office/drawing/2016/SVG/main" r:embed="rId4"/>
               </a:ext>
             </a:extLst>
           </a:blip>
@@ -7822,11 +7827,11 @@
               <a:rPr lang="en-US" sz="1200" dirty="0">
                 <a:hlinkClick r:id="rId2"/>
               </a:rPr>
-              <a:t>https://cwe.mitre.org/data/definitions/787.html</a:t>
+              <a:t>https://cwe.mitre.org/top25/archive/2025/2025_kev_list.html</a:t>
             </a:r>
             <a:r>
               <a:rPr lang="en-US" sz="1200" dirty="0"/>
-              <a:t> [Last Access: 09. Dec. 2025]</a:t>
+              <a:t> [Last Access: 14. May 2026]</a:t>
             </a:r>
           </a:p>
           <a:p>
@@ -7842,7 +7847,7 @@
             </a:r>
             <a:r>
               <a:rPr lang="en-US" sz="1200" dirty="0"/>
-              <a:t> [Last Access: 09. Dec. 2025]</a:t>
+              <a:t> [Last Access: 14. May 2026]</a:t>
             </a:r>
           </a:p>
           <a:p>
@@ -7854,43 +7859,11 @@
               <a:rPr lang="en-US" sz="1200" dirty="0">
                 <a:hlinkClick r:id="rId4"/>
               </a:rPr>
-              <a:t>https://cwe.mitre.org/top25/archive/2024/2024_kev_insights.html</a:t>
+              <a:t>http://cwe.mitre.org/data/definitions/787.html</a:t>
             </a:r>
             <a:r>
               <a:rPr lang="en-US" sz="1200" dirty="0"/>
-              <a:t> [Last Access: 09. Dec. 2025]</a:t>
-            </a:r>
-          </a:p>
-          <a:p>
-            <a:pPr>
-              <a:buFont typeface="+mj-lt"/>
-              <a:buAutoNum type="arabicPeriod"/>
-            </a:pPr>
-            <a:r>
-              <a:rPr lang="en-US" sz="1200" dirty="0">
-                <a:hlinkClick r:id="rId5"/>
-              </a:rPr>
-              <a:t>http://www.pl-enthusiast.net/2014/07/21/memory-safety/</a:t>
-            </a:r>
-            <a:r>
-              <a:rPr lang="en-US" sz="1200" dirty="0"/>
-              <a:t> [Last Access: 10. Dec. 2025]</a:t>
-            </a:r>
-          </a:p>
-          <a:p>
-            <a:pPr>
-              <a:buFont typeface="+mj-lt"/>
-              <a:buAutoNum type="arabicPeriod"/>
-            </a:pPr>
-            <a:r>
-              <a:rPr lang="en-US" sz="1200" dirty="0">
-                <a:hlinkClick r:id="rId6"/>
-              </a:rPr>
-              <a:t>https://cset.georgetown.edu/article/memory-safety-an-explainer/</a:t>
-            </a:r>
-            <a:r>
-              <a:rPr lang="en-US" sz="1200" dirty="0"/>
-              <a:t> [Last Access: 10. Dec. 2025]</a:t>
+              <a:t> [Last Access: 14. May 2026]</a:t>
             </a:r>
           </a:p>
           <a:p>
@@ -7907,12 +7880,269 @@
             </a:pPr>
             <a:endParaRPr lang="en-US" sz="1200" dirty="0"/>
           </a:p>
+          <a:p>
+            <a:pPr>
+              <a:buFont typeface="+mj-lt"/>
+              <a:buAutoNum type="arabicPeriod"/>
+            </a:pPr>
+            <a:endParaRPr lang="en-US" sz="1200" dirty="0"/>
+          </a:p>
         </p:txBody>
       </p:sp>
     </p:spTree>
     <p:extLst>
       <p:ext uri="{BB962C8B-B14F-4D97-AF65-F5344CB8AC3E}">
         <p14:creationId xmlns:p14="http://schemas.microsoft.com/office/powerpoint/2010/main" val="2402372695"/>
+      </p:ext>
+    </p:extLst>
+  </p:cSld>
+  <p:clrMapOvr>
+    <a:masterClrMapping/>
+  </p:clrMapOvr>
+</p:sld>
+</file>
+
+<file path=ppt/slides/slide17.xml><?xml version="1.0" encoding="utf-8"?>
+<p:sld xmlns:a="http://schemas.openxmlformats.org/drawingml/2006/main" xmlns:r="http://schemas.openxmlformats.org/officeDocument/2006/relationships" xmlns:p="http://schemas.openxmlformats.org/presentationml/2006/main">
+  <p:cSld>
+    <p:spTree>
+      <p:nvGrpSpPr>
+        <p:cNvPr id="1" name="">
+          <a:extLst>
+            <a:ext uri="{FF2B5EF4-FFF2-40B4-BE49-F238E27FC236}">
+              <a16:creationId xmlns:a16="http://schemas.microsoft.com/office/drawing/2014/main" id="{7725AB0C-C8AB-6DBD-B205-1B516DBBBED2}"/>
+            </a:ext>
+          </a:extLst>
+        </p:cNvPr>
+        <p:cNvGrpSpPr/>
+        <p:nvPr/>
+      </p:nvGrpSpPr>
+      <p:grpSpPr>
+        <a:xfrm>
+          <a:off x="0" y="0"/>
+          <a:ext cx="0" cy="0"/>
+          <a:chOff x="0" y="0"/>
+          <a:chExt cx="0" cy="0"/>
+        </a:xfrm>
+      </p:grpSpPr>
+      <p:sp>
+        <p:nvSpPr>
+          <p:cNvPr id="2" name="Fußzeilenplatzhalter 1">
+            <a:extLst>
+              <a:ext uri="{FF2B5EF4-FFF2-40B4-BE49-F238E27FC236}">
+                <a16:creationId xmlns:a16="http://schemas.microsoft.com/office/drawing/2014/main" id="{63142F7C-CE89-7FB8-18A8-C76EBEA0E7DA}"/>
+              </a:ext>
+            </a:extLst>
+          </p:cNvPr>
+          <p:cNvSpPr>
+            <a:spLocks noGrp="1"/>
+          </p:cNvSpPr>
+          <p:nvPr>
+            <p:ph type="ftr" sz="quarter" idx="10"/>
+          </p:nvPr>
+        </p:nvSpPr>
+        <p:spPr/>
+        <p:txBody>
+          <a:bodyPr/>
+          <a:lstStyle/>
+          <a:p>
+            <a:r>
+              <a:rPr lang="en-US">
+                <a:solidFill>
+                  <a:srgbClr val="64378C"/>
+                </a:solidFill>
+              </a:rPr>
+              <a:t>Rust's Approach to Memory Safety</a:t>
+            </a:r>
+            <a:endParaRPr lang="en-US" dirty="0">
+              <a:solidFill>
+                <a:srgbClr val="64378C"/>
+              </a:solidFill>
+            </a:endParaRPr>
+          </a:p>
+        </p:txBody>
+      </p:sp>
+      <p:sp>
+        <p:nvSpPr>
+          <p:cNvPr id="3" name="Foliennummernplatzhalter 2">
+            <a:extLst>
+              <a:ext uri="{FF2B5EF4-FFF2-40B4-BE49-F238E27FC236}">
+                <a16:creationId xmlns:a16="http://schemas.microsoft.com/office/drawing/2014/main" id="{F51B70DA-453D-856E-6BC1-097A9905B571}"/>
+              </a:ext>
+            </a:extLst>
+          </p:cNvPr>
+          <p:cNvSpPr>
+            <a:spLocks noGrp="1"/>
+          </p:cNvSpPr>
+          <p:nvPr>
+            <p:ph type="sldNum" sz="quarter" idx="11"/>
+          </p:nvPr>
+        </p:nvSpPr>
+        <p:spPr/>
+        <p:txBody>
+          <a:bodyPr/>
+          <a:lstStyle/>
+          <a:p>
+            <a:pPr algn="ctr"/>
+            <a:fld id="{5F85D455-7770-4F98-B944-71C158B4E906}" type="slidenum">
+              <a:rPr lang="en-US" smtClean="0"/>
+              <a:pPr algn="ctr"/>
+              <a:t>17</a:t>
+            </a:fld>
+            <a:endParaRPr lang="en-US" dirty="0"/>
+          </a:p>
+        </p:txBody>
+      </p:sp>
+      <p:sp>
+        <p:nvSpPr>
+          <p:cNvPr id="4" name="Textplatzhalter 3">
+            <a:extLst>
+              <a:ext uri="{FF2B5EF4-FFF2-40B4-BE49-F238E27FC236}">
+                <a16:creationId xmlns:a16="http://schemas.microsoft.com/office/drawing/2014/main" id="{80E04E80-D003-2FAD-718F-8EC5BA371226}"/>
+              </a:ext>
+            </a:extLst>
+          </p:cNvPr>
+          <p:cNvSpPr>
+            <a:spLocks noGrp="1"/>
+          </p:cNvSpPr>
+          <p:nvPr>
+            <p:ph type="body" sz="quarter" idx="12"/>
+          </p:nvPr>
+        </p:nvSpPr>
+        <p:spPr/>
+        <p:txBody>
+          <a:bodyPr/>
+          <a:lstStyle/>
+          <a:p>
+            <a:r>
+              <a:rPr lang="en-US" dirty="0"/>
+              <a:t>Sources</a:t>
+            </a:r>
+          </a:p>
+        </p:txBody>
+      </p:sp>
+      <p:sp>
+        <p:nvSpPr>
+          <p:cNvPr id="5" name="Inhaltsplatzhalter 4">
+            <a:extLst>
+              <a:ext uri="{FF2B5EF4-FFF2-40B4-BE49-F238E27FC236}">
+                <a16:creationId xmlns:a16="http://schemas.microsoft.com/office/drawing/2014/main" id="{CD9AFA94-6EB5-A8F6-E797-2E3565C175A8}"/>
+              </a:ext>
+            </a:extLst>
+          </p:cNvPr>
+          <p:cNvSpPr>
+            <a:spLocks noGrp="1"/>
+          </p:cNvSpPr>
+          <p:nvPr>
+            <p:ph sz="quarter" idx="13"/>
+          </p:nvPr>
+        </p:nvSpPr>
+        <p:spPr/>
+        <p:txBody>
+          <a:bodyPr>
+            <a:normAutofit/>
+          </a:bodyPr>
+          <a:lstStyle/>
+          <a:p>
+            <a:pPr>
+              <a:buFont typeface="+mj-lt"/>
+              <a:buAutoNum type="arabicPeriod"/>
+            </a:pPr>
+            <a:r>
+              <a:rPr lang="en-US" sz="1200" dirty="0">
+                <a:hlinkClick r:id="rId2"/>
+              </a:rPr>
+              <a:t>https://cwe.mitre.org/data/definitions/787.html</a:t>
+            </a:r>
+            <a:r>
+              <a:rPr lang="en-US" sz="1200" dirty="0"/>
+              <a:t> [Last Access: 09. Dec. 2025]</a:t>
+            </a:r>
+          </a:p>
+          <a:p>
+            <a:pPr>
+              <a:buFont typeface="+mj-lt"/>
+              <a:buAutoNum type="arabicPeriod"/>
+            </a:pPr>
+            <a:r>
+              <a:rPr lang="en-US" sz="1200" dirty="0">
+                <a:hlinkClick r:id="rId3"/>
+              </a:rPr>
+              <a:t>https://cwe.mitre.org/data/definitions/416.html</a:t>
+            </a:r>
+            <a:r>
+              <a:rPr lang="en-US" sz="1200" dirty="0"/>
+              <a:t> [Last Access: 09. Dec. 2025]</a:t>
+            </a:r>
+          </a:p>
+          <a:p>
+            <a:pPr>
+              <a:buFont typeface="+mj-lt"/>
+              <a:buAutoNum type="arabicPeriod"/>
+            </a:pPr>
+            <a:r>
+              <a:rPr lang="en-US" sz="1200" dirty="0">
+                <a:hlinkClick r:id="rId4"/>
+              </a:rPr>
+              <a:t>https://cwe.mitre.org/top25/archive/2024/2024_kev_insights.html</a:t>
+            </a:r>
+            <a:r>
+              <a:rPr lang="en-US" sz="1200" dirty="0"/>
+              <a:t> [Last Access: 09. Dec. 2025]</a:t>
+            </a:r>
+          </a:p>
+          <a:p>
+            <a:pPr>
+              <a:buFont typeface="+mj-lt"/>
+              <a:buAutoNum type="arabicPeriod"/>
+            </a:pPr>
+            <a:r>
+              <a:rPr lang="en-US" sz="1200" dirty="0">
+                <a:hlinkClick r:id="rId5"/>
+              </a:rPr>
+              <a:t>http://www.pl-enthusiast.net/2014/07/21/memory-safety/</a:t>
+            </a:r>
+            <a:r>
+              <a:rPr lang="en-US" sz="1200" dirty="0"/>
+              <a:t> [Last Access: 10. Dec. 2025]</a:t>
+            </a:r>
+          </a:p>
+          <a:p>
+            <a:pPr>
+              <a:buFont typeface="+mj-lt"/>
+              <a:buAutoNum type="arabicPeriod"/>
+            </a:pPr>
+            <a:r>
+              <a:rPr lang="en-US" sz="1200" dirty="0">
+                <a:hlinkClick r:id="rId6"/>
+              </a:rPr>
+              <a:t>https://cset.georgetown.edu/article/memory-safety-an-explainer/</a:t>
+            </a:r>
+            <a:r>
+              <a:rPr lang="en-US" sz="1200" dirty="0"/>
+              <a:t> [Last Access: 10. Dec. 2025]</a:t>
+            </a:r>
+          </a:p>
+          <a:p>
+            <a:pPr>
+              <a:buFont typeface="+mj-lt"/>
+              <a:buAutoNum type="arabicPeriod"/>
+            </a:pPr>
+            <a:endParaRPr lang="en-US" sz="1200" dirty="0"/>
+          </a:p>
+          <a:p>
+            <a:pPr>
+              <a:buFont typeface="+mj-lt"/>
+              <a:buAutoNum type="arabicPeriod"/>
+            </a:pPr>
+            <a:endParaRPr lang="en-US" sz="1200" dirty="0"/>
+          </a:p>
+        </p:txBody>
+      </p:sp>
+    </p:spTree>
+    <p:extLst>
+      <p:ext uri="{BB962C8B-B14F-4D97-AF65-F5344CB8AC3E}">
+        <p14:creationId xmlns:p14="http://schemas.microsoft.com/office/powerpoint/2010/main" val="215978853"/>
       </p:ext>
     </p:extLst>
   </p:cSld>
@@ -8086,10 +8316,10 @@
           <p:nvPr/>
         </p:nvPicPr>
         <p:blipFill>
-          <a:blip r:embed="rId2">
+          <a:blip>
             <a:extLst>
               <a:ext uri="{96DAC541-7B7A-43D3-8B79-37D633B846F1}">
-                <asvg:svgBlip xmlns:asvg="http://schemas.microsoft.com/office/drawing/2016/SVG/main" r:embed="rId3"/>
+                <asvg:svgBlip xmlns:asvg="http://schemas.microsoft.com/office/drawing/2016/SVG/main" r:embed="rId2"/>
               </a:ext>
             </a:extLst>
           </a:blip>
@@ -8122,10 +8352,10 @@
           <p:nvPr/>
         </p:nvPicPr>
         <p:blipFill>
-          <a:blip r:embed="rId4">
+          <a:blip>
             <a:extLst>
               <a:ext uri="{96DAC541-7B7A-43D3-8B79-37D633B846F1}">
-                <asvg:svgBlip xmlns:asvg="http://schemas.microsoft.com/office/drawing/2016/SVG/main" r:embed="rId5"/>
+                <asvg:svgBlip xmlns:asvg="http://schemas.microsoft.com/office/drawing/2016/SVG/main" r:embed="rId3"/>
               </a:ext>
             </a:extLst>
           </a:blip>
@@ -8175,47 +8405,6 @@
       </p:grpSpPr>
       <p:sp>
         <p:nvSpPr>
-          <p:cNvPr id="21" name="Textfeld 20">
-            <a:extLst>
-              <a:ext uri="{FF2B5EF4-FFF2-40B4-BE49-F238E27FC236}">
-                <a16:creationId xmlns:a16="http://schemas.microsoft.com/office/drawing/2014/main" id="{7E44D345-9269-3655-FEA9-0954976BCC70}"/>
-              </a:ext>
-            </a:extLst>
-          </p:cNvPr>
-          <p:cNvSpPr txBox="1"/>
-          <p:nvPr/>
-        </p:nvSpPr>
-        <p:spPr>
-          <a:xfrm>
-            <a:off x="1203513" y="1827737"/>
-            <a:ext cx="3919816" cy="365125"/>
-          </a:xfrm>
-          <a:prstGeom prst="rect">
-            <a:avLst/>
-          </a:prstGeom>
-          <a:noFill/>
-          <a:ln>
-            <a:solidFill>
-              <a:schemeClr val="accent1"/>
-            </a:solidFill>
-          </a:ln>
-        </p:spPr>
-        <p:txBody>
-          <a:bodyPr wrap="square" rtlCol="0">
-            <a:noAutofit/>
-          </a:bodyPr>
-          <a:lstStyle/>
-          <a:p>
-            <a:pPr algn="ctr"/>
-            <a:r>
-              <a:rPr lang="en-US" b="1" dirty="0"/>
-              <a:t>Out-of-bounds Write</a:t>
-            </a:r>
-          </a:p>
-        </p:txBody>
-      </p:sp>
-      <p:sp>
-        <p:nvSpPr>
           <p:cNvPr id="2" name="Fußzeilenplatzhalter 1">
             <a:extLst>
               <a:ext uri="{FF2B5EF4-FFF2-40B4-BE49-F238E27FC236}">
@@ -8343,51 +8532,20 @@
               <a:rPr lang="en-US" dirty="0"/>
               <a:t>The following two errors are among the 10 most common:</a:t>
             </a:r>
-          </a:p>
-        </p:txBody>
-      </p:sp>
-      <p:pic>
-        <p:nvPicPr>
-          <p:cNvPr id="17" name="Grafik 16" descr="Trophäe mit einfarbiger Füllung">
-            <a:extLst>
-              <a:ext uri="{FF2B5EF4-FFF2-40B4-BE49-F238E27FC236}">
-                <a16:creationId xmlns:a16="http://schemas.microsoft.com/office/drawing/2014/main" id="{4C4A2DBB-9913-F351-799D-21929FD32E84}"/>
-              </a:ext>
-            </a:extLst>
-          </p:cNvPr>
-          <p:cNvPicPr>
-            <a:picLocks noChangeAspect="1"/>
-          </p:cNvPicPr>
-          <p:nvPr/>
-        </p:nvPicPr>
-        <p:blipFill>
-          <a:blip r:embed="rId2">
-            <a:extLst>
-              <a:ext uri="{96DAC541-7B7A-43D3-8B79-37D633B846F1}">
-                <asvg:svgBlip xmlns:asvg="http://schemas.microsoft.com/office/drawing/2016/SVG/main" r:embed="rId3"/>
-              </a:ext>
-            </a:extLst>
-          </a:blip>
-          <a:stretch>
-            <a:fillRect/>
-          </a:stretch>
-        </p:blipFill>
-        <p:spPr>
-          <a:xfrm>
-            <a:off x="1274623" y="1647278"/>
-            <a:ext cx="705627" cy="705627"/>
-          </a:xfrm>
-          <a:prstGeom prst="rect">
-            <a:avLst/>
-          </a:prstGeom>
-        </p:spPr>
-      </p:pic>
-      <p:sp>
-        <p:nvSpPr>
-          <p:cNvPr id="18" name="Textfeld 17">
-            <a:extLst>
-              <a:ext uri="{FF2B5EF4-FFF2-40B4-BE49-F238E27FC236}">
-                <a16:creationId xmlns:a16="http://schemas.microsoft.com/office/drawing/2014/main" id="{8C18E31E-3E91-1C65-EA81-6E58B10ED6CC}"/>
+            <a:r>
+              <a:rPr lang="en-US" sz="1200" baseline="-25000" dirty="0"/>
+              <a:t>[1]</a:t>
+            </a:r>
+            <a:endParaRPr lang="en-US" baseline="-25000" dirty="0"/>
+          </a:p>
+        </p:txBody>
+      </p:sp>
+      <p:sp>
+        <p:nvSpPr>
+          <p:cNvPr id="22" name="Textfeld 21">
+            <a:extLst>
+              <a:ext uri="{FF2B5EF4-FFF2-40B4-BE49-F238E27FC236}">
+                <a16:creationId xmlns:a16="http://schemas.microsoft.com/office/drawing/2014/main" id="{D481B7BC-27CF-2608-A157-AB224B25E885}"/>
               </a:ext>
             </a:extLst>
           </p:cNvPr>
@@ -8396,47 +8554,7 @@
         </p:nvSpPr>
         <p:spPr>
           <a:xfrm>
-            <a:off x="1518476" y="1719310"/>
-            <a:ext cx="217920" cy="338554"/>
-          </a:xfrm>
-          <a:prstGeom prst="rect">
-            <a:avLst/>
-          </a:prstGeom>
-          <a:noFill/>
-        </p:spPr>
-        <p:txBody>
-          <a:bodyPr wrap="square" rtlCol="0">
-            <a:spAutoFit/>
-          </a:bodyPr>
-          <a:lstStyle/>
-          <a:p>
-            <a:pPr algn="ctr"/>
-            <a:r>
-              <a:rPr lang="en-US" sz="1600" dirty="0">
-                <a:solidFill>
-                  <a:schemeClr val="bg1"/>
-                </a:solidFill>
-              </a:rPr>
-              <a:t>1</a:t>
-            </a:r>
-          </a:p>
-        </p:txBody>
-      </p:sp>
-      <p:sp>
-        <p:nvSpPr>
-          <p:cNvPr id="22" name="Textfeld 21">
-            <a:extLst>
-              <a:ext uri="{FF2B5EF4-FFF2-40B4-BE49-F238E27FC236}">
-                <a16:creationId xmlns:a16="http://schemas.microsoft.com/office/drawing/2014/main" id="{D481B7BC-27CF-2608-A157-AB224B25E885}"/>
-              </a:ext>
-            </a:extLst>
-          </p:cNvPr>
-          <p:cNvSpPr txBox="1"/>
-          <p:nvPr/>
-        </p:nvSpPr>
-        <p:spPr>
-          <a:xfrm>
-            <a:off x="6400803" y="1828507"/>
+            <a:off x="1457513" y="1723196"/>
             <a:ext cx="3919816" cy="364355"/>
           </a:xfrm>
           <a:prstGeom prst="rect">
@@ -8463,12 +8581,93 @@
           </a:p>
         </p:txBody>
       </p:sp>
-      <p:sp>
-        <p:nvSpPr>
-          <p:cNvPr id="23" name="Rechteck: abgerundete Ecken 22">
-            <a:extLst>
-              <a:ext uri="{FF2B5EF4-FFF2-40B4-BE49-F238E27FC236}">
-                <a16:creationId xmlns:a16="http://schemas.microsoft.com/office/drawing/2014/main" id="{6968F378-6BE4-7063-1D88-41051242A5ED}"/>
+      <p:pic>
+        <p:nvPicPr>
+          <p:cNvPr id="50" name="Grafik 49" descr="Trophäe mit einfarbiger Füllung">
+            <a:extLst>
+              <a:ext uri="{FF2B5EF4-FFF2-40B4-BE49-F238E27FC236}">
+                <a16:creationId xmlns:a16="http://schemas.microsoft.com/office/drawing/2014/main" id="{841EA221-080D-7E6F-A66D-FFBAA0AA0617}"/>
+              </a:ext>
+            </a:extLst>
+          </p:cNvPr>
+          <p:cNvPicPr>
+            <a:picLocks noChangeAspect="1"/>
+          </p:cNvPicPr>
+          <p:nvPr/>
+        </p:nvPicPr>
+        <p:blipFill>
+          <a:blip>
+            <a:extLst>
+              <a:ext uri="{96DAC541-7B7A-43D3-8B79-37D633B846F1}">
+                <asvg:svgBlip xmlns:asvg="http://schemas.microsoft.com/office/drawing/2016/SVG/main" r:embed="rId2"/>
+              </a:ext>
+            </a:extLst>
+          </a:blip>
+          <a:stretch>
+            <a:fillRect/>
+          </a:stretch>
+        </p:blipFill>
+        <p:spPr>
+          <a:xfrm>
+            <a:off x="1533104" y="1541967"/>
+            <a:ext cx="705627" cy="705627"/>
+          </a:xfrm>
+          <a:prstGeom prst="rect">
+            <a:avLst/>
+          </a:prstGeom>
+        </p:spPr>
+      </p:pic>
+      <p:sp>
+        <p:nvSpPr>
+          <p:cNvPr id="51" name="Textfeld 50">
+            <a:extLst>
+              <a:ext uri="{FF2B5EF4-FFF2-40B4-BE49-F238E27FC236}">
+                <a16:creationId xmlns:a16="http://schemas.microsoft.com/office/drawing/2014/main" id="{DD2F39DA-5598-EB76-6AC1-4E66B8848EB1}"/>
+              </a:ext>
+            </a:extLst>
+          </p:cNvPr>
+          <p:cNvSpPr txBox="1"/>
+          <p:nvPr/>
+        </p:nvSpPr>
+        <p:spPr>
+          <a:xfrm>
+            <a:off x="1776957" y="1613999"/>
+            <a:ext cx="217920" cy="338554"/>
+          </a:xfrm>
+          <a:prstGeom prst="rect">
+            <a:avLst/>
+          </a:prstGeom>
+          <a:noFill/>
+        </p:spPr>
+        <p:txBody>
+          <a:bodyPr wrap="square" rtlCol="0">
+            <a:spAutoFit/>
+          </a:bodyPr>
+          <a:lstStyle/>
+          <a:p>
+            <a:pPr algn="ctr"/>
+            <a:r>
+              <a:rPr lang="de-DE" sz="1600" dirty="0">
+                <a:solidFill>
+                  <a:schemeClr val="bg1"/>
+                </a:solidFill>
+              </a:rPr>
+              <a:t>2</a:t>
+            </a:r>
+            <a:endParaRPr lang="en-US" sz="1600" dirty="0">
+              <a:solidFill>
+                <a:schemeClr val="bg1"/>
+              </a:solidFill>
+            </a:endParaRPr>
+          </a:p>
+        </p:txBody>
+      </p:sp>
+      <p:sp>
+        <p:nvSpPr>
+          <p:cNvPr id="52" name="Rechteck: abgerundete Ecken 51">
+            <a:extLst>
+              <a:ext uri="{FF2B5EF4-FFF2-40B4-BE49-F238E27FC236}">
+                <a16:creationId xmlns:a16="http://schemas.microsoft.com/office/drawing/2014/main" id="{83341C1B-EDAA-941B-6575-416920D9D477}"/>
               </a:ext>
             </a:extLst>
           </p:cNvPr>
@@ -8477,7 +8676,7 @@
         </p:nvSpPr>
         <p:spPr>
           <a:xfrm>
-            <a:off x="1714499" y="2620129"/>
+            <a:off x="1968500" y="2514818"/>
             <a:ext cx="2897842" cy="914400"/>
           </a:xfrm>
           <a:prstGeom prst="roundRect">
@@ -8514,10 +8713,10 @@
       </p:sp>
       <p:sp>
         <p:nvSpPr>
-          <p:cNvPr id="24" name="Rechteck: abgerundete Ecken 23">
-            <a:extLst>
-              <a:ext uri="{FF2B5EF4-FFF2-40B4-BE49-F238E27FC236}">
-                <a16:creationId xmlns:a16="http://schemas.microsoft.com/office/drawing/2014/main" id="{1F316013-4FB0-C839-9220-7E36ECEB70D2}"/>
+          <p:cNvPr id="53" name="Rechteck: abgerundete Ecken 52">
+            <a:extLst>
+              <a:ext uri="{FF2B5EF4-FFF2-40B4-BE49-F238E27FC236}">
+                <a16:creationId xmlns:a16="http://schemas.microsoft.com/office/drawing/2014/main" id="{03387FE7-576F-0B25-E181-6387F4A70926}"/>
               </a:ext>
             </a:extLst>
           </p:cNvPr>
@@ -8526,501 +8725,7 @@
         </p:nvSpPr>
         <p:spPr>
           <a:xfrm>
-            <a:off x="2373406" y="2620129"/>
-            <a:ext cx="1580029" cy="914400"/>
-          </a:xfrm>
-          <a:prstGeom prst="roundRect">
-            <a:avLst/>
-          </a:prstGeom>
-          <a:solidFill>
-            <a:srgbClr val="64378C">
-              <a:alpha val="80000"/>
-            </a:srgbClr>
-          </a:solidFill>
-        </p:spPr>
-        <p:style>
-          <a:lnRef idx="2">
-            <a:schemeClr val="accent1">
-              <a:shade val="15000"/>
-            </a:schemeClr>
-          </a:lnRef>
-          <a:fillRef idx="1">
-            <a:schemeClr val="accent1"/>
-          </a:fillRef>
-          <a:effectRef idx="0">
-            <a:schemeClr val="accent1"/>
-          </a:effectRef>
-          <a:fontRef idx="minor">
-            <a:schemeClr val="lt1"/>
-          </a:fontRef>
-        </p:style>
-        <p:txBody>
-          <a:bodyPr rtlCol="0" anchor="ctr"/>
-          <a:lstStyle/>
-          <a:p>
-            <a:pPr algn="ctr"/>
-            <a:r>
-              <a:rPr lang="en-US" dirty="0"/>
-              <a:t>Buffer</a:t>
-            </a:r>
-          </a:p>
-        </p:txBody>
-      </p:sp>
-      <p:cxnSp>
-        <p:nvCxnSpPr>
-          <p:cNvPr id="26" name="Verbinder: gekrümmt 25">
-            <a:extLst>
-              <a:ext uri="{FF2B5EF4-FFF2-40B4-BE49-F238E27FC236}">
-                <a16:creationId xmlns:a16="http://schemas.microsoft.com/office/drawing/2014/main" id="{8D311970-567C-B52D-8E00-CF813F056A75}"/>
-              </a:ext>
-            </a:extLst>
-          </p:cNvPr>
-          <p:cNvCxnSpPr>
-            <a:cxnSpLocks/>
-            <a:stCxn id="40" idx="1"/>
-          </p:cNvCxnSpPr>
-          <p:nvPr/>
-        </p:nvCxnSpPr>
-        <p:spPr>
-          <a:xfrm rot="10800000">
-            <a:off x="2030506" y="3077330"/>
-            <a:ext cx="705626" cy="1024761"/>
-          </a:xfrm>
-          <a:prstGeom prst="curvedConnector2">
-            <a:avLst/>
-          </a:prstGeom>
-          <a:ln>
-            <a:solidFill>
-              <a:schemeClr val="tx1"/>
-            </a:solidFill>
-            <a:tailEnd type="triangle"/>
-          </a:ln>
-        </p:spPr>
-        <p:style>
-          <a:lnRef idx="2">
-            <a:schemeClr val="accent1"/>
-          </a:lnRef>
-          <a:fillRef idx="0">
-            <a:schemeClr val="accent1"/>
-          </a:fillRef>
-          <a:effectRef idx="1">
-            <a:schemeClr val="accent1"/>
-          </a:effectRef>
-          <a:fontRef idx="minor">
-            <a:schemeClr val="tx1"/>
-          </a:fontRef>
-        </p:style>
-      </p:cxnSp>
-      <p:cxnSp>
-        <p:nvCxnSpPr>
-          <p:cNvPr id="32" name="Verbinder: gekrümmt 31">
-            <a:extLst>
-              <a:ext uri="{FF2B5EF4-FFF2-40B4-BE49-F238E27FC236}">
-                <a16:creationId xmlns:a16="http://schemas.microsoft.com/office/drawing/2014/main" id="{A5BA6F9F-68B0-4A50-E6EC-0FBC2E076F2A}"/>
-              </a:ext>
-            </a:extLst>
-          </p:cNvPr>
-          <p:cNvCxnSpPr>
-            <a:cxnSpLocks/>
-            <a:stCxn id="40" idx="3"/>
-          </p:cNvCxnSpPr>
-          <p:nvPr/>
-        </p:nvCxnSpPr>
-        <p:spPr>
-          <a:xfrm flipV="1">
-            <a:off x="3590708" y="3077329"/>
-            <a:ext cx="752692" cy="1024761"/>
-          </a:xfrm>
-          <a:prstGeom prst="curvedConnector2">
-            <a:avLst/>
-          </a:prstGeom>
-          <a:ln cap="sq">
-            <a:solidFill>
-              <a:schemeClr val="tx1"/>
-            </a:solidFill>
-            <a:round/>
-            <a:tailEnd type="triangle"/>
-          </a:ln>
-        </p:spPr>
-        <p:style>
-          <a:lnRef idx="2">
-            <a:schemeClr val="accent1"/>
-          </a:lnRef>
-          <a:fillRef idx="0">
-            <a:schemeClr val="accent1"/>
-          </a:fillRef>
-          <a:effectRef idx="1">
-            <a:schemeClr val="accent1"/>
-          </a:effectRef>
-          <a:fontRef idx="minor">
-            <a:schemeClr val="tx1"/>
-          </a:fontRef>
-        </p:style>
-      </p:cxnSp>
-      <p:sp>
-        <p:nvSpPr>
-          <p:cNvPr id="40" name="Textfeld 39">
-            <a:extLst>
-              <a:ext uri="{FF2B5EF4-FFF2-40B4-BE49-F238E27FC236}">
-                <a16:creationId xmlns:a16="http://schemas.microsoft.com/office/drawing/2014/main" id="{97CCE4A7-1466-BACF-8F8F-5B188D22CC03}"/>
-              </a:ext>
-            </a:extLst>
-          </p:cNvPr>
-          <p:cNvSpPr txBox="1"/>
-          <p:nvPr/>
-        </p:nvSpPr>
-        <p:spPr>
-          <a:xfrm>
-            <a:off x="2736132" y="3917424"/>
-            <a:ext cx="854576" cy="369332"/>
-          </a:xfrm>
-          <a:prstGeom prst="rect">
-            <a:avLst/>
-          </a:prstGeom>
-          <a:noFill/>
-        </p:spPr>
-        <p:txBody>
-          <a:bodyPr wrap="square" rtlCol="0">
-            <a:spAutoFit/>
-          </a:bodyPr>
-          <a:lstStyle/>
-          <a:p>
-            <a:pPr algn="ctr"/>
-            <a:r>
-              <a:rPr lang="en-US" dirty="0"/>
-              <a:t>Write</a:t>
-            </a:r>
-          </a:p>
-        </p:txBody>
-      </p:sp>
-      <p:pic>
-        <p:nvPicPr>
-          <p:cNvPr id="46" name="Grafik 45" descr="Blitz Silhouette">
-            <a:extLst>
-              <a:ext uri="{FF2B5EF4-FFF2-40B4-BE49-F238E27FC236}">
-                <a16:creationId xmlns:a16="http://schemas.microsoft.com/office/drawing/2014/main" id="{9CADF224-05A1-1EDA-D24F-9859F9B4225A}"/>
-              </a:ext>
-            </a:extLst>
-          </p:cNvPr>
-          <p:cNvPicPr>
-            <a:picLocks noChangeAspect="1"/>
-          </p:cNvPicPr>
-          <p:nvPr/>
-        </p:nvPicPr>
-        <p:blipFill>
-          <a:blip r:embed="rId4">
-            <a:extLst>
-              <a:ext uri="{96DAC541-7B7A-43D3-8B79-37D633B846F1}">
-                <asvg:svgBlip xmlns:asvg="http://schemas.microsoft.com/office/drawing/2016/SVG/main" r:embed="rId5"/>
-              </a:ext>
-            </a:extLst>
-          </a:blip>
-          <a:stretch>
-            <a:fillRect/>
-          </a:stretch>
-        </p:blipFill>
-        <p:spPr>
-          <a:xfrm>
-            <a:off x="4112745" y="3661249"/>
-            <a:ext cx="365125" cy="365125"/>
-          </a:xfrm>
-          <a:prstGeom prst="rect">
-            <a:avLst/>
-          </a:prstGeom>
-          <a:effectLst>
-            <a:outerShdw blurRad="50800" dist="50800" dir="5400000" algn="ctr" rotWithShape="0">
-              <a:srgbClr val="FF0000"/>
-            </a:outerShdw>
-          </a:effectLst>
-        </p:spPr>
-      </p:pic>
-      <p:pic>
-        <p:nvPicPr>
-          <p:cNvPr id="47" name="Grafik 46" descr="Blitz Silhouette">
-            <a:extLst>
-              <a:ext uri="{FF2B5EF4-FFF2-40B4-BE49-F238E27FC236}">
-                <a16:creationId xmlns:a16="http://schemas.microsoft.com/office/drawing/2014/main" id="{2912EDC6-7BF7-ED6B-BCFA-F9938E68BA64}"/>
-              </a:ext>
-            </a:extLst>
-          </p:cNvPr>
-          <p:cNvPicPr>
-            <a:picLocks noChangeAspect="1"/>
-          </p:cNvPicPr>
-          <p:nvPr/>
-        </p:nvPicPr>
-        <p:blipFill>
-          <a:blip r:embed="rId4">
-            <a:extLst>
-              <a:ext uri="{96DAC541-7B7A-43D3-8B79-37D633B846F1}">
-                <asvg:svgBlip xmlns:asvg="http://schemas.microsoft.com/office/drawing/2016/SVG/main" r:embed="rId5"/>
-              </a:ext>
-            </a:extLst>
-          </a:blip>
-          <a:stretch>
-            <a:fillRect/>
-          </a:stretch>
-        </p:blipFill>
-        <p:spPr>
-          <a:xfrm>
-            <a:off x="1896035" y="3657241"/>
-            <a:ext cx="365125" cy="365125"/>
-          </a:xfrm>
-          <a:prstGeom prst="rect">
-            <a:avLst/>
-          </a:prstGeom>
-          <a:effectLst>
-            <a:outerShdw blurRad="50800" dist="50800" dir="5400000" algn="ctr" rotWithShape="0">
-              <a:srgbClr val="FF0000"/>
-            </a:outerShdw>
-          </a:effectLst>
-        </p:spPr>
-      </p:pic>
-      <p:graphicFrame>
-        <p:nvGraphicFramePr>
-          <p:cNvPr id="49" name="Tabelle 48">
-            <a:extLst>
-              <a:ext uri="{FF2B5EF4-FFF2-40B4-BE49-F238E27FC236}">
-                <a16:creationId xmlns:a16="http://schemas.microsoft.com/office/drawing/2014/main" id="{0BD2B105-29CE-0FC8-C7D7-6B895C2AE100}"/>
-              </a:ext>
-            </a:extLst>
-          </p:cNvPr>
-          <p:cNvGraphicFramePr>
-            <a:graphicFrameLocks noGrp="1"/>
-          </p:cNvGraphicFramePr>
-          <p:nvPr>
-            <p:extLst>
-              <p:ext uri="{D42A27DB-BD31-4B8C-83A1-F6EECF244321}">
-                <p14:modId xmlns:p14="http://schemas.microsoft.com/office/powerpoint/2010/main" val="1699261347"/>
-              </p:ext>
-            </p:extLst>
-          </p:nvPr>
-        </p:nvGraphicFramePr>
-        <p:xfrm>
-          <a:off x="1203512" y="4522804"/>
-          <a:ext cx="3919816" cy="1515545"/>
-        </p:xfrm>
-        <a:graphic>
-          <a:graphicData uri="http://schemas.openxmlformats.org/drawingml/2006/table">
-            <a:tbl>
-              <a:tblPr/>
-              <a:tblGrid>
-                <a:gridCol w="3919816">
-                  <a:extLst>
-                    <a:ext uri="{9D8B030D-6E8A-4147-A177-3AD203B41FA5}">
-                      <a16:colId xmlns:a16="http://schemas.microsoft.com/office/drawing/2014/main" val="3050072985"/>
-                    </a:ext>
-                  </a:extLst>
-                </a:gridCol>
-              </a:tblGrid>
-              <a:tr h="1515545">
-                <a:tc>
-                  <a:txBody>
-                    <a:bodyPr/>
-                    <a:lstStyle/>
-                    <a:p>
-                      <a:pPr algn="ctr">
-                        <a:buNone/>
-                      </a:pPr>
-                      <a:r>
-                        <a:rPr lang="en-US" dirty="0">
-                          <a:effectLst/>
-                          <a:latin typeface="Verdana" panose="020B0604030504040204" pitchFamily="34" charset="0"/>
-                        </a:rPr>
-                        <a:t>“</a:t>
-                      </a:r>
-                      <a:r>
-                        <a:rPr lang="en-US" i="1" dirty="0">
-                          <a:effectLst/>
-                          <a:latin typeface="Verdana" panose="020B0604030504040204" pitchFamily="34" charset="0"/>
-                        </a:rPr>
-                        <a:t>The product writes data past the end, or before the beginning, of the intended buffer.</a:t>
-                      </a:r>
-                      <a:r>
-                        <a:rPr lang="en-US" i="0" dirty="0">
-                          <a:effectLst/>
-                          <a:latin typeface="Verdana" panose="020B0604030504040204" pitchFamily="34" charset="0"/>
-                        </a:rPr>
-                        <a:t>”</a:t>
-                      </a:r>
-                      <a:r>
-                        <a:rPr lang="en-US" i="0" baseline="-25000" dirty="0">
-                          <a:effectLst/>
-                          <a:latin typeface="Verdana" panose="020B0604030504040204" pitchFamily="34" charset="0"/>
-                        </a:rPr>
-                        <a:t>[1]</a:t>
-                      </a:r>
-                      <a:endParaRPr lang="en-US" i="1" baseline="-25000" dirty="0">
-                        <a:effectLst/>
-                        <a:latin typeface="Verdana" panose="020B0604030504040204" pitchFamily="34" charset="0"/>
-                      </a:endParaRPr>
-                    </a:p>
-                  </a:txBody>
-                  <a:tcPr anchor="ctr">
-                    <a:lnL>
-                      <a:noFill/>
-                    </a:lnL>
-                    <a:lnR>
-                      <a:noFill/>
-                    </a:lnR>
-                    <a:lnT>
-                      <a:noFill/>
-                    </a:lnT>
-                    <a:lnB>
-                      <a:noFill/>
-                    </a:lnB>
-                    <a:noFill/>
-                  </a:tcPr>
-                </a:tc>
-                <a:extLst>
-                  <a:ext uri="{0D108BD9-81ED-4DB2-BD59-A6C34878D82A}">
-                    <a16:rowId xmlns:a16="http://schemas.microsoft.com/office/drawing/2014/main" val="326503797"/>
-                  </a:ext>
-                </a:extLst>
-              </a:tr>
-            </a:tbl>
-          </a:graphicData>
-        </a:graphic>
-      </p:graphicFrame>
-      <p:pic>
-        <p:nvPicPr>
-          <p:cNvPr id="50" name="Grafik 49" descr="Trophäe mit einfarbiger Füllung">
-            <a:extLst>
-              <a:ext uri="{FF2B5EF4-FFF2-40B4-BE49-F238E27FC236}">
-                <a16:creationId xmlns:a16="http://schemas.microsoft.com/office/drawing/2014/main" id="{841EA221-080D-7E6F-A66D-FFBAA0AA0617}"/>
-              </a:ext>
-            </a:extLst>
-          </p:cNvPr>
-          <p:cNvPicPr>
-            <a:picLocks noChangeAspect="1"/>
-          </p:cNvPicPr>
-          <p:nvPr/>
-        </p:nvPicPr>
-        <p:blipFill>
-          <a:blip r:embed="rId2">
-            <a:extLst>
-              <a:ext uri="{96DAC541-7B7A-43D3-8B79-37D633B846F1}">
-                <asvg:svgBlip xmlns:asvg="http://schemas.microsoft.com/office/drawing/2016/SVG/main" r:embed="rId3"/>
-              </a:ext>
-            </a:extLst>
-          </a:blip>
-          <a:stretch>
-            <a:fillRect/>
-          </a:stretch>
-        </p:blipFill>
-        <p:spPr>
-          <a:xfrm>
-            <a:off x="6476394" y="1647278"/>
-            <a:ext cx="705627" cy="705627"/>
-          </a:xfrm>
-          <a:prstGeom prst="rect">
-            <a:avLst/>
-          </a:prstGeom>
-        </p:spPr>
-      </p:pic>
-      <p:sp>
-        <p:nvSpPr>
-          <p:cNvPr id="51" name="Textfeld 50">
-            <a:extLst>
-              <a:ext uri="{FF2B5EF4-FFF2-40B4-BE49-F238E27FC236}">
-                <a16:creationId xmlns:a16="http://schemas.microsoft.com/office/drawing/2014/main" id="{DD2F39DA-5598-EB76-6AC1-4E66B8848EB1}"/>
-              </a:ext>
-            </a:extLst>
-          </p:cNvPr>
-          <p:cNvSpPr txBox="1"/>
-          <p:nvPr/>
-        </p:nvSpPr>
-        <p:spPr>
-          <a:xfrm>
-            <a:off x="6720247" y="1719310"/>
-            <a:ext cx="217920" cy="338554"/>
-          </a:xfrm>
-          <a:prstGeom prst="rect">
-            <a:avLst/>
-          </a:prstGeom>
-          <a:noFill/>
-        </p:spPr>
-        <p:txBody>
-          <a:bodyPr wrap="square" rtlCol="0">
-            <a:spAutoFit/>
-          </a:bodyPr>
-          <a:lstStyle/>
-          <a:p>
-            <a:pPr algn="ctr"/>
-            <a:r>
-              <a:rPr lang="en-US" sz="1600" dirty="0">
-                <a:solidFill>
-                  <a:schemeClr val="bg1"/>
-                </a:solidFill>
-              </a:rPr>
-              <a:t>9</a:t>
-            </a:r>
-          </a:p>
-        </p:txBody>
-      </p:sp>
-      <p:sp>
-        <p:nvSpPr>
-          <p:cNvPr id="52" name="Rechteck: abgerundete Ecken 51">
-            <a:extLst>
-              <a:ext uri="{FF2B5EF4-FFF2-40B4-BE49-F238E27FC236}">
-                <a16:creationId xmlns:a16="http://schemas.microsoft.com/office/drawing/2014/main" id="{83341C1B-EDAA-941B-6575-416920D9D477}"/>
-              </a:ext>
-            </a:extLst>
-          </p:cNvPr>
-          <p:cNvSpPr/>
-          <p:nvPr/>
-        </p:nvSpPr>
-        <p:spPr>
-          <a:xfrm>
-            <a:off x="6911790" y="2620129"/>
-            <a:ext cx="2897842" cy="914400"/>
-          </a:xfrm>
-          <a:prstGeom prst="roundRect">
-            <a:avLst/>
-          </a:prstGeom>
-          <a:solidFill>
-            <a:schemeClr val="bg1"/>
-          </a:solidFill>
-        </p:spPr>
-        <p:style>
-          <a:lnRef idx="2">
-            <a:schemeClr val="accent1">
-              <a:shade val="15000"/>
-            </a:schemeClr>
-          </a:lnRef>
-          <a:fillRef idx="1">
-            <a:schemeClr val="accent1"/>
-          </a:fillRef>
-          <a:effectRef idx="0">
-            <a:schemeClr val="accent1"/>
-          </a:effectRef>
-          <a:fontRef idx="minor">
-            <a:schemeClr val="lt1"/>
-          </a:fontRef>
-        </p:style>
-        <p:txBody>
-          <a:bodyPr rtlCol="0" anchor="ctr"/>
-          <a:lstStyle/>
-          <a:p>
-            <a:pPr algn="ctr"/>
-            <a:endParaRPr lang="en-US"/>
-          </a:p>
-        </p:txBody>
-      </p:sp>
-      <p:sp>
-        <p:nvSpPr>
-          <p:cNvPr id="53" name="Rechteck: abgerundete Ecken 52">
-            <a:extLst>
-              <a:ext uri="{FF2B5EF4-FFF2-40B4-BE49-F238E27FC236}">
-                <a16:creationId xmlns:a16="http://schemas.microsoft.com/office/drawing/2014/main" id="{03387FE7-576F-0B25-E181-6387F4A70926}"/>
-              </a:ext>
-            </a:extLst>
-          </p:cNvPr>
-          <p:cNvSpPr/>
-          <p:nvPr/>
-        </p:nvSpPr>
-        <p:spPr>
-          <a:xfrm>
-            <a:off x="7182022" y="2620129"/>
+            <a:off x="2238732" y="2514818"/>
             <a:ext cx="1598908" cy="916460"/>
           </a:xfrm>
           <a:custGeom>
@@ -9212,14 +8917,14 @@
           <p:nvPr>
             <p:extLst>
               <p:ext uri="{D42A27DB-BD31-4B8C-83A1-F6EECF244321}">
-                <p14:modId xmlns:p14="http://schemas.microsoft.com/office/powerpoint/2010/main" val="3242806567"/>
+                <p14:modId xmlns:p14="http://schemas.microsoft.com/office/powerpoint/2010/main" val="3158724234"/>
               </p:ext>
             </p:extLst>
           </p:nvPr>
         </p:nvGraphicFramePr>
         <p:xfrm>
-          <a:off x="6400803" y="4522804"/>
-          <a:ext cx="3919816" cy="1515545"/>
+          <a:off x="1457513" y="4576243"/>
+          <a:ext cx="3919816" cy="1198037"/>
         </p:xfrm>
         <a:graphic>
           <a:graphicData uri="http://schemas.openxmlformats.org/drawingml/2006/table">
@@ -9234,7 +8939,7 @@
                   </a:extLst>
                 </a:gridCol>
               </a:tblGrid>
-              <a:tr h="1515545">
+              <a:tr h="1198037">
                 <a:tc>
                   <a:txBody>
                     <a:bodyPr/>
@@ -9265,19 +8970,19 @@
                         <a:t>”</a:t>
                       </a:r>
                       <a:r>
-                        <a:rPr lang="en-US" i="0" baseline="-25000" dirty="0">
+                        <a:rPr lang="en-US" sz="1200" i="0" baseline="-25000" dirty="0">
                           <a:effectLst/>
                           <a:latin typeface="Verdana" panose="020B0604030504040204" pitchFamily="34" charset="0"/>
                         </a:rPr>
                         <a:t>[2]</a:t>
                       </a:r>
-                      <a:endParaRPr lang="en-US" i="1" baseline="-25000" dirty="0">
+                      <a:endParaRPr lang="en-US" sz="1800" i="1" baseline="-25000" dirty="0">
                         <a:effectLst/>
                         <a:latin typeface="Verdana" panose="020B0604030504040204" pitchFamily="34" charset="0"/>
                       </a:endParaRPr>
                     </a:p>
                   </a:txBody>
-                  <a:tcPr anchor="ctr">
+                  <a:tcPr>
                     <a:lnL>
                       <a:noFill/>
                     </a:lnL>
@@ -9317,7 +9022,7 @@
         </p:nvSpPr>
         <p:spPr>
           <a:xfrm>
-            <a:off x="8823573" y="3917423"/>
+            <a:off x="3880283" y="3812112"/>
             <a:ext cx="918822" cy="369332"/>
           </a:xfrm>
           <a:prstGeom prst="rect">
@@ -9353,7 +9058,7 @@
         </p:nvSpPr>
         <p:spPr>
           <a:xfrm>
-            <a:off x="6589059" y="3917423"/>
+            <a:off x="1645769" y="3812112"/>
             <a:ext cx="655472" cy="369332"/>
           </a:xfrm>
           <a:prstGeom prst="rect">
@@ -9392,7 +9097,7 @@
         </p:nvCxnSpPr>
         <p:spPr>
           <a:xfrm flipV="1">
-            <a:off x="7244531" y="3534530"/>
+            <a:off x="2301241" y="3429219"/>
             <a:ext cx="406844" cy="567559"/>
           </a:xfrm>
           <a:prstGeom prst="curvedConnector2">
@@ -9438,7 +9143,7 @@
         </p:nvCxnSpPr>
         <p:spPr>
           <a:xfrm rot="10800000">
-            <a:off x="8350929" y="3533501"/>
+            <a:off x="3407639" y="3428190"/>
             <a:ext cx="472644" cy="568588"/>
           </a:xfrm>
           <a:prstGeom prst="curvedConnector2">
@@ -9481,10 +9186,10 @@
           <p:nvPr/>
         </p:nvPicPr>
         <p:blipFill>
-          <a:blip r:embed="rId4">
+          <a:blip>
             <a:extLst>
               <a:ext uri="{96DAC541-7B7A-43D3-8B79-37D633B846F1}">
-                <asvg:svgBlip xmlns:asvg="http://schemas.microsoft.com/office/drawing/2016/SVG/main" r:embed="rId5"/>
+                <asvg:svgBlip xmlns:asvg="http://schemas.microsoft.com/office/drawing/2016/SVG/main" r:embed="rId3"/>
               </a:ext>
             </a:extLst>
           </a:blip>
@@ -9494,7 +9199,7 @@
         </p:blipFill>
         <p:spPr>
           <a:xfrm>
-            <a:off x="8514415" y="3612095"/>
+            <a:off x="3571125" y="3506784"/>
             <a:ext cx="365125" cy="365125"/>
           </a:xfrm>
           <a:prstGeom prst="rect">
@@ -9522,10 +9227,10 @@
           <p:nvPr/>
         </p:nvPicPr>
         <p:blipFill>
-          <a:blip r:embed="rId6">
+          <a:blip>
             <a:extLst>
               <a:ext uri="{96DAC541-7B7A-43D3-8B79-37D633B846F1}">
-                <asvg:svgBlip xmlns:asvg="http://schemas.microsoft.com/office/drawing/2016/SVG/main" r:embed="rId7"/>
+                <asvg:svgBlip xmlns:asvg="http://schemas.microsoft.com/office/drawing/2016/SVG/main" r:embed="rId4"/>
               </a:ext>
             </a:extLst>
           </a:blip>
@@ -9535,7 +9240,7 @@
         </p:blipFill>
         <p:spPr>
           <a:xfrm>
-            <a:off x="6476394" y="3995459"/>
+            <a:off x="1533104" y="3890148"/>
             <a:ext cx="207706" cy="207706"/>
           </a:xfrm>
           <a:prstGeom prst="rect">
@@ -9558,10 +9263,10 @@
           <p:nvPr/>
         </p:nvPicPr>
         <p:blipFill>
-          <a:blip r:embed="rId8">
+          <a:blip>
             <a:extLst>
               <a:ext uri="{96DAC541-7B7A-43D3-8B79-37D633B846F1}">
-                <asvg:svgBlip xmlns:asvg="http://schemas.microsoft.com/office/drawing/2016/SVG/main" r:embed="rId9"/>
+                <asvg:svgBlip xmlns:asvg="http://schemas.microsoft.com/office/drawing/2016/SVG/main" r:embed="rId5"/>
               </a:ext>
             </a:extLst>
           </a:blip>
@@ -9571,7 +9276,7 @@
         </p:blipFill>
         <p:spPr>
           <a:xfrm>
-            <a:off x="9669015" y="3995459"/>
+            <a:off x="4709002" y="3910235"/>
             <a:ext cx="207706" cy="207706"/>
           </a:xfrm>
           <a:prstGeom prst="rect">
@@ -9579,6 +9284,594 @@
           </a:prstGeom>
         </p:spPr>
       </p:pic>
+      <p:sp>
+        <p:nvSpPr>
+          <p:cNvPr id="8" name="Textfeld 7">
+            <a:extLst>
+              <a:ext uri="{FF2B5EF4-FFF2-40B4-BE49-F238E27FC236}">
+                <a16:creationId xmlns:a16="http://schemas.microsoft.com/office/drawing/2014/main" id="{2FA757B5-AF5C-368D-3DE9-62C0D5D1E39F}"/>
+              </a:ext>
+            </a:extLst>
+          </p:cNvPr>
+          <p:cNvSpPr txBox="1"/>
+          <p:nvPr/>
+        </p:nvSpPr>
+        <p:spPr>
+          <a:xfrm>
+            <a:off x="6483727" y="1722426"/>
+            <a:ext cx="3919816" cy="365125"/>
+          </a:xfrm>
+          <a:prstGeom prst="rect">
+            <a:avLst/>
+          </a:prstGeom>
+          <a:noFill/>
+          <a:ln>
+            <a:solidFill>
+              <a:schemeClr val="accent1"/>
+            </a:solidFill>
+          </a:ln>
+        </p:spPr>
+        <p:txBody>
+          <a:bodyPr wrap="square" rtlCol="0">
+            <a:noAutofit/>
+          </a:bodyPr>
+          <a:lstStyle/>
+          <a:p>
+            <a:pPr algn="ctr"/>
+            <a:r>
+              <a:rPr lang="en-US" b="1" dirty="0"/>
+              <a:t>Out-of-bounds Write</a:t>
+            </a:r>
+          </a:p>
+        </p:txBody>
+      </p:sp>
+      <p:pic>
+        <p:nvPicPr>
+          <p:cNvPr id="9" name="Grafik 8" descr="Trophäe mit einfarbiger Füllung">
+            <a:extLst>
+              <a:ext uri="{FF2B5EF4-FFF2-40B4-BE49-F238E27FC236}">
+                <a16:creationId xmlns:a16="http://schemas.microsoft.com/office/drawing/2014/main" id="{1AE40962-3352-F6C8-3E94-624BD7C7CFD4}"/>
+              </a:ext>
+            </a:extLst>
+          </p:cNvPr>
+          <p:cNvPicPr>
+            <a:picLocks noChangeAspect="1"/>
+          </p:cNvPicPr>
+          <p:nvPr/>
+        </p:nvPicPr>
+        <p:blipFill>
+          <a:blip>
+            <a:extLst>
+              <a:ext uri="{96DAC541-7B7A-43D3-8B79-37D633B846F1}">
+                <asvg:svgBlip xmlns:asvg="http://schemas.microsoft.com/office/drawing/2016/SVG/main" r:embed="rId2"/>
+              </a:ext>
+            </a:extLst>
+          </a:blip>
+          <a:stretch>
+            <a:fillRect/>
+          </a:stretch>
+        </p:blipFill>
+        <p:spPr>
+          <a:xfrm>
+            <a:off x="6554837" y="1541967"/>
+            <a:ext cx="705627" cy="705627"/>
+          </a:xfrm>
+          <a:prstGeom prst="rect">
+            <a:avLst/>
+          </a:prstGeom>
+        </p:spPr>
+      </p:pic>
+      <p:sp>
+        <p:nvSpPr>
+          <p:cNvPr id="10" name="Textfeld 9">
+            <a:extLst>
+              <a:ext uri="{FF2B5EF4-FFF2-40B4-BE49-F238E27FC236}">
+                <a16:creationId xmlns:a16="http://schemas.microsoft.com/office/drawing/2014/main" id="{3E163E3F-1A27-C5E5-9B0E-EBA062ADE2D5}"/>
+              </a:ext>
+            </a:extLst>
+          </p:cNvPr>
+          <p:cNvSpPr txBox="1"/>
+          <p:nvPr/>
+        </p:nvSpPr>
+        <p:spPr>
+          <a:xfrm>
+            <a:off x="6798690" y="1613999"/>
+            <a:ext cx="217920" cy="338554"/>
+          </a:xfrm>
+          <a:prstGeom prst="rect">
+            <a:avLst/>
+          </a:prstGeom>
+          <a:noFill/>
+        </p:spPr>
+        <p:txBody>
+          <a:bodyPr wrap="square" rtlCol="0">
+            <a:spAutoFit/>
+          </a:bodyPr>
+          <a:lstStyle/>
+          <a:p>
+            <a:pPr algn="ctr"/>
+            <a:r>
+              <a:rPr lang="de-DE" sz="1600" dirty="0">
+                <a:solidFill>
+                  <a:schemeClr val="bg1"/>
+                </a:solidFill>
+              </a:rPr>
+              <a:t>3</a:t>
+            </a:r>
+            <a:endParaRPr lang="en-US" sz="1600" dirty="0">
+              <a:solidFill>
+                <a:schemeClr val="bg1"/>
+              </a:solidFill>
+            </a:endParaRPr>
+          </a:p>
+        </p:txBody>
+      </p:sp>
+      <p:sp>
+        <p:nvSpPr>
+          <p:cNvPr id="11" name="Rechteck: abgerundete Ecken 10">
+            <a:extLst>
+              <a:ext uri="{FF2B5EF4-FFF2-40B4-BE49-F238E27FC236}">
+                <a16:creationId xmlns:a16="http://schemas.microsoft.com/office/drawing/2014/main" id="{659793A4-1DB8-A425-25C5-3BE28C45F86A}"/>
+              </a:ext>
+            </a:extLst>
+          </p:cNvPr>
+          <p:cNvSpPr/>
+          <p:nvPr/>
+        </p:nvSpPr>
+        <p:spPr>
+          <a:xfrm>
+            <a:off x="6994713" y="2514818"/>
+            <a:ext cx="2897842" cy="914400"/>
+          </a:xfrm>
+          <a:prstGeom prst="roundRect">
+            <a:avLst/>
+          </a:prstGeom>
+          <a:solidFill>
+            <a:schemeClr val="bg1"/>
+          </a:solidFill>
+        </p:spPr>
+        <p:style>
+          <a:lnRef idx="2">
+            <a:schemeClr val="accent1">
+              <a:shade val="15000"/>
+            </a:schemeClr>
+          </a:lnRef>
+          <a:fillRef idx="1">
+            <a:schemeClr val="accent1"/>
+          </a:fillRef>
+          <a:effectRef idx="0">
+            <a:schemeClr val="accent1"/>
+          </a:effectRef>
+          <a:fontRef idx="minor">
+            <a:schemeClr val="lt1"/>
+          </a:fontRef>
+        </p:style>
+        <p:txBody>
+          <a:bodyPr rtlCol="0" anchor="ctr"/>
+          <a:lstStyle/>
+          <a:p>
+            <a:pPr algn="ctr"/>
+            <a:endParaRPr lang="en-US"/>
+          </a:p>
+        </p:txBody>
+      </p:sp>
+      <p:sp>
+        <p:nvSpPr>
+          <p:cNvPr id="12" name="Rechteck: abgerundete Ecken 11">
+            <a:extLst>
+              <a:ext uri="{FF2B5EF4-FFF2-40B4-BE49-F238E27FC236}">
+                <a16:creationId xmlns:a16="http://schemas.microsoft.com/office/drawing/2014/main" id="{5CC290DA-C221-425B-C1A1-E071CB307F49}"/>
+              </a:ext>
+            </a:extLst>
+          </p:cNvPr>
+          <p:cNvSpPr/>
+          <p:nvPr/>
+        </p:nvSpPr>
+        <p:spPr>
+          <a:xfrm>
+            <a:off x="7653620" y="2514818"/>
+            <a:ext cx="1580029" cy="914400"/>
+          </a:xfrm>
+          <a:prstGeom prst="roundRect">
+            <a:avLst/>
+          </a:prstGeom>
+          <a:solidFill>
+            <a:srgbClr val="64378C">
+              <a:alpha val="80000"/>
+            </a:srgbClr>
+          </a:solidFill>
+        </p:spPr>
+        <p:style>
+          <a:lnRef idx="2">
+            <a:schemeClr val="accent1">
+              <a:shade val="15000"/>
+            </a:schemeClr>
+          </a:lnRef>
+          <a:fillRef idx="1">
+            <a:schemeClr val="accent1"/>
+          </a:fillRef>
+          <a:effectRef idx="0">
+            <a:schemeClr val="accent1"/>
+          </a:effectRef>
+          <a:fontRef idx="minor">
+            <a:schemeClr val="lt1"/>
+          </a:fontRef>
+        </p:style>
+        <p:txBody>
+          <a:bodyPr rtlCol="0" anchor="ctr"/>
+          <a:lstStyle/>
+          <a:p>
+            <a:pPr algn="ctr"/>
+            <a:r>
+              <a:rPr lang="en-US" dirty="0"/>
+              <a:t>Buffer</a:t>
+            </a:r>
+          </a:p>
+        </p:txBody>
+      </p:sp>
+      <p:cxnSp>
+        <p:nvCxnSpPr>
+          <p:cNvPr id="13" name="Verbinder: gekrümmt 12">
+            <a:extLst>
+              <a:ext uri="{FF2B5EF4-FFF2-40B4-BE49-F238E27FC236}">
+                <a16:creationId xmlns:a16="http://schemas.microsoft.com/office/drawing/2014/main" id="{5D2D87B8-7CCC-2EAE-100C-AB0E43D6EBA0}"/>
+              </a:ext>
+            </a:extLst>
+          </p:cNvPr>
+          <p:cNvCxnSpPr>
+            <a:cxnSpLocks/>
+            <a:stCxn id="15" idx="1"/>
+          </p:cNvCxnSpPr>
+          <p:nvPr/>
+        </p:nvCxnSpPr>
+        <p:spPr>
+          <a:xfrm rot="10800000">
+            <a:off x="7310720" y="2972019"/>
+            <a:ext cx="705626" cy="1024761"/>
+          </a:xfrm>
+          <a:prstGeom prst="curvedConnector2">
+            <a:avLst/>
+          </a:prstGeom>
+          <a:ln>
+            <a:solidFill>
+              <a:schemeClr val="tx1"/>
+            </a:solidFill>
+            <a:tailEnd type="triangle"/>
+          </a:ln>
+        </p:spPr>
+        <p:style>
+          <a:lnRef idx="2">
+            <a:schemeClr val="accent1"/>
+          </a:lnRef>
+          <a:fillRef idx="0">
+            <a:schemeClr val="accent1"/>
+          </a:fillRef>
+          <a:effectRef idx="1">
+            <a:schemeClr val="accent1"/>
+          </a:effectRef>
+          <a:fontRef idx="minor">
+            <a:schemeClr val="tx1"/>
+          </a:fontRef>
+        </p:style>
+      </p:cxnSp>
+      <p:cxnSp>
+        <p:nvCxnSpPr>
+          <p:cNvPr id="14" name="Verbinder: gekrümmt 13">
+            <a:extLst>
+              <a:ext uri="{FF2B5EF4-FFF2-40B4-BE49-F238E27FC236}">
+                <a16:creationId xmlns:a16="http://schemas.microsoft.com/office/drawing/2014/main" id="{619A7805-E345-019B-152D-031CBEE7B4E3}"/>
+              </a:ext>
+            </a:extLst>
+          </p:cNvPr>
+          <p:cNvCxnSpPr>
+            <a:cxnSpLocks/>
+            <a:stCxn id="15" idx="3"/>
+          </p:cNvCxnSpPr>
+          <p:nvPr/>
+        </p:nvCxnSpPr>
+        <p:spPr>
+          <a:xfrm flipV="1">
+            <a:off x="8870922" y="2972018"/>
+            <a:ext cx="752692" cy="1024761"/>
+          </a:xfrm>
+          <a:prstGeom prst="curvedConnector2">
+            <a:avLst/>
+          </a:prstGeom>
+          <a:ln cap="sq">
+            <a:solidFill>
+              <a:schemeClr val="tx1"/>
+            </a:solidFill>
+            <a:round/>
+            <a:tailEnd type="triangle"/>
+          </a:ln>
+        </p:spPr>
+        <p:style>
+          <a:lnRef idx="2">
+            <a:schemeClr val="accent1"/>
+          </a:lnRef>
+          <a:fillRef idx="0">
+            <a:schemeClr val="accent1"/>
+          </a:fillRef>
+          <a:effectRef idx="1">
+            <a:schemeClr val="accent1"/>
+          </a:effectRef>
+          <a:fontRef idx="minor">
+            <a:schemeClr val="tx1"/>
+          </a:fontRef>
+        </p:style>
+      </p:cxnSp>
+      <p:sp>
+        <p:nvSpPr>
+          <p:cNvPr id="15" name="Textfeld 14">
+            <a:extLst>
+              <a:ext uri="{FF2B5EF4-FFF2-40B4-BE49-F238E27FC236}">
+                <a16:creationId xmlns:a16="http://schemas.microsoft.com/office/drawing/2014/main" id="{75240762-8C36-2191-9ABC-9D0E666015A2}"/>
+              </a:ext>
+            </a:extLst>
+          </p:cNvPr>
+          <p:cNvSpPr txBox="1"/>
+          <p:nvPr/>
+        </p:nvSpPr>
+        <p:spPr>
+          <a:xfrm>
+            <a:off x="8016346" y="3812113"/>
+            <a:ext cx="854576" cy="369332"/>
+          </a:xfrm>
+          <a:prstGeom prst="rect">
+            <a:avLst/>
+          </a:prstGeom>
+          <a:noFill/>
+        </p:spPr>
+        <p:txBody>
+          <a:bodyPr wrap="square" rtlCol="0">
+            <a:spAutoFit/>
+          </a:bodyPr>
+          <a:lstStyle/>
+          <a:p>
+            <a:pPr algn="ctr"/>
+            <a:r>
+              <a:rPr lang="en-US" dirty="0"/>
+              <a:t>Write</a:t>
+            </a:r>
+          </a:p>
+        </p:txBody>
+      </p:sp>
+      <p:pic>
+        <p:nvPicPr>
+          <p:cNvPr id="16" name="Grafik 15" descr="Blitz Silhouette">
+            <a:extLst>
+              <a:ext uri="{FF2B5EF4-FFF2-40B4-BE49-F238E27FC236}">
+                <a16:creationId xmlns:a16="http://schemas.microsoft.com/office/drawing/2014/main" id="{851EA5DF-9FAE-8226-9CF2-B5B4580E1181}"/>
+              </a:ext>
+            </a:extLst>
+          </p:cNvPr>
+          <p:cNvPicPr>
+            <a:picLocks noChangeAspect="1"/>
+          </p:cNvPicPr>
+          <p:nvPr/>
+        </p:nvPicPr>
+        <p:blipFill>
+          <a:blip>
+            <a:extLst>
+              <a:ext uri="{96DAC541-7B7A-43D3-8B79-37D633B846F1}">
+                <asvg:svgBlip xmlns:asvg="http://schemas.microsoft.com/office/drawing/2016/SVG/main" r:embed="rId3"/>
+              </a:ext>
+            </a:extLst>
+          </a:blip>
+          <a:stretch>
+            <a:fillRect/>
+          </a:stretch>
+        </p:blipFill>
+        <p:spPr>
+          <a:xfrm>
+            <a:off x="9392959" y="3555938"/>
+            <a:ext cx="365125" cy="365125"/>
+          </a:xfrm>
+          <a:prstGeom prst="rect">
+            <a:avLst/>
+          </a:prstGeom>
+          <a:effectLst>
+            <a:outerShdw blurRad="50800" dist="50800" dir="5400000" algn="ctr" rotWithShape="0">
+              <a:srgbClr val="FF0000"/>
+            </a:outerShdw>
+          </a:effectLst>
+        </p:spPr>
+      </p:pic>
+      <p:pic>
+        <p:nvPicPr>
+          <p:cNvPr id="19" name="Grafik 18" descr="Blitz Silhouette">
+            <a:extLst>
+              <a:ext uri="{FF2B5EF4-FFF2-40B4-BE49-F238E27FC236}">
+                <a16:creationId xmlns:a16="http://schemas.microsoft.com/office/drawing/2014/main" id="{46A75C5B-8612-9B89-D3FA-27A5C9963973}"/>
+              </a:ext>
+            </a:extLst>
+          </p:cNvPr>
+          <p:cNvPicPr>
+            <a:picLocks noChangeAspect="1"/>
+          </p:cNvPicPr>
+          <p:nvPr/>
+        </p:nvPicPr>
+        <p:blipFill>
+          <a:blip>
+            <a:extLst>
+              <a:ext uri="{96DAC541-7B7A-43D3-8B79-37D633B846F1}">
+                <asvg:svgBlip xmlns:asvg="http://schemas.microsoft.com/office/drawing/2016/SVG/main" r:embed="rId3"/>
+              </a:ext>
+            </a:extLst>
+          </a:blip>
+          <a:stretch>
+            <a:fillRect/>
+          </a:stretch>
+        </p:blipFill>
+        <p:spPr>
+          <a:xfrm>
+            <a:off x="7176249" y="3551930"/>
+            <a:ext cx="365125" cy="365125"/>
+          </a:xfrm>
+          <a:prstGeom prst="rect">
+            <a:avLst/>
+          </a:prstGeom>
+          <a:effectLst>
+            <a:outerShdw blurRad="50800" dist="50800" dir="5400000" algn="ctr" rotWithShape="0">
+              <a:srgbClr val="FF0000"/>
+            </a:outerShdw>
+          </a:effectLst>
+        </p:spPr>
+      </p:pic>
+      <p:graphicFrame>
+        <p:nvGraphicFramePr>
+          <p:cNvPr id="20" name="Tabelle 19">
+            <a:extLst>
+              <a:ext uri="{FF2B5EF4-FFF2-40B4-BE49-F238E27FC236}">
+                <a16:creationId xmlns:a16="http://schemas.microsoft.com/office/drawing/2014/main" id="{3E36B04F-9F57-C50A-6105-5D2846C453D4}"/>
+              </a:ext>
+            </a:extLst>
+          </p:cNvPr>
+          <p:cNvGraphicFramePr>
+            <a:graphicFrameLocks noGrp="1"/>
+          </p:cNvGraphicFramePr>
+          <p:nvPr>
+            <p:extLst>
+              <p:ext uri="{D42A27DB-BD31-4B8C-83A1-F6EECF244321}">
+                <p14:modId xmlns:p14="http://schemas.microsoft.com/office/powerpoint/2010/main" val="912908518"/>
+              </p:ext>
+            </p:extLst>
+          </p:nvPr>
+        </p:nvGraphicFramePr>
+        <p:xfrm>
+          <a:off x="6483726" y="4576243"/>
+          <a:ext cx="3919816" cy="1198037"/>
+        </p:xfrm>
+        <a:graphic>
+          <a:graphicData uri="http://schemas.openxmlformats.org/drawingml/2006/table">
+            <a:tbl>
+              <a:tblPr/>
+              <a:tblGrid>
+                <a:gridCol w="3919816">
+                  <a:extLst>
+                    <a:ext uri="{9D8B030D-6E8A-4147-A177-3AD203B41FA5}">
+                      <a16:colId xmlns:a16="http://schemas.microsoft.com/office/drawing/2014/main" val="3050072985"/>
+                    </a:ext>
+                  </a:extLst>
+                </a:gridCol>
+              </a:tblGrid>
+              <a:tr h="1198037">
+                <a:tc>
+                  <a:txBody>
+                    <a:bodyPr/>
+                    <a:lstStyle/>
+                    <a:p>
+                      <a:pPr algn="ctr">
+                        <a:buNone/>
+                      </a:pPr>
+                      <a:r>
+                        <a:rPr lang="en-US" dirty="0">
+                          <a:effectLst/>
+                          <a:latin typeface="Verdana" panose="020B0604030504040204" pitchFamily="34" charset="0"/>
+                        </a:rPr>
+                        <a:t>“</a:t>
+                      </a:r>
+                      <a:r>
+                        <a:rPr lang="en-US" i="1" dirty="0">
+                          <a:effectLst/>
+                          <a:latin typeface="Verdana" panose="020B0604030504040204" pitchFamily="34" charset="0"/>
+                        </a:rPr>
+                        <a:t>The product writes data past the end, or before the beginning, of the intended buffer.</a:t>
+                      </a:r>
+                      <a:r>
+                        <a:rPr lang="en-US" i="0" dirty="0">
+                          <a:effectLst/>
+                          <a:latin typeface="Verdana" panose="020B0604030504040204" pitchFamily="34" charset="0"/>
+                        </a:rPr>
+                        <a:t>”</a:t>
+                      </a:r>
+                      <a:r>
+                        <a:rPr lang="en-US" sz="1200" i="0" baseline="-25000" dirty="0">
+                          <a:effectLst/>
+                          <a:latin typeface="Verdana" panose="020B0604030504040204" pitchFamily="34" charset="0"/>
+                        </a:rPr>
+                        <a:t>[3]</a:t>
+                      </a:r>
+                      <a:endParaRPr lang="en-US" i="1" baseline="-25000" dirty="0">
+                        <a:effectLst/>
+                        <a:latin typeface="Verdana" panose="020B0604030504040204" pitchFamily="34" charset="0"/>
+                      </a:endParaRPr>
+                    </a:p>
+                  </a:txBody>
+                  <a:tcPr>
+                    <a:lnL>
+                      <a:noFill/>
+                    </a:lnL>
+                    <a:lnR>
+                      <a:noFill/>
+                    </a:lnR>
+                    <a:lnT>
+                      <a:noFill/>
+                    </a:lnT>
+                    <a:lnB>
+                      <a:noFill/>
+                    </a:lnB>
+                    <a:noFill/>
+                  </a:tcPr>
+                </a:tc>
+                <a:extLst>
+                  <a:ext uri="{0D108BD9-81ED-4DB2-BD59-A6C34878D82A}">
+                    <a16:rowId xmlns:a16="http://schemas.microsoft.com/office/drawing/2014/main" val="326503797"/>
+                  </a:ext>
+                </a:extLst>
+              </a:tr>
+            </a:tbl>
+          </a:graphicData>
+        </a:graphic>
+      </p:graphicFrame>
+      <p:sp>
+        <p:nvSpPr>
+          <p:cNvPr id="25" name="Textfeld 24">
+            <a:extLst>
+              <a:ext uri="{FF2B5EF4-FFF2-40B4-BE49-F238E27FC236}">
+                <a16:creationId xmlns:a16="http://schemas.microsoft.com/office/drawing/2014/main" id="{BDC2007B-C6BF-F967-A89A-BE8AF506A4B2}"/>
+              </a:ext>
+            </a:extLst>
+          </p:cNvPr>
+          <p:cNvSpPr txBox="1"/>
+          <p:nvPr/>
+        </p:nvSpPr>
+        <p:spPr>
+          <a:xfrm>
+            <a:off x="1092200" y="5899150"/>
+            <a:ext cx="9642287" cy="461665"/>
+          </a:xfrm>
+          <a:prstGeom prst="rect">
+            <a:avLst/>
+          </a:prstGeom>
+          <a:noFill/>
+        </p:spPr>
+        <p:txBody>
+          <a:bodyPr wrap="square" rtlCol="0">
+            <a:spAutoFit/>
+          </a:bodyPr>
+          <a:lstStyle/>
+          <a:p>
+            <a:r>
+              <a:rPr lang="de-DE" sz="800" dirty="0"/>
+              <a:t>[1] https://cwe.mitre.org/top25/archive/2025/2025_kev_list.html</a:t>
+            </a:r>
+          </a:p>
+          <a:p>
+            <a:r>
+              <a:rPr lang="de-DE" sz="800" dirty="0"/>
+              <a:t>[2] https://cwe.mitre.org/data/definitions/416.html</a:t>
+            </a:r>
+          </a:p>
+          <a:p>
+            <a:r>
+              <a:rPr lang="de-DE" sz="800" dirty="0"/>
+              <a:t>[3] https://cwe.mitre.org/data/definitions/787.html</a:t>
+            </a:r>
+            <a:endParaRPr lang="en-US" sz="800" dirty="0"/>
+          </a:p>
+        </p:txBody>
+      </p:sp>
     </p:spTree>
     <p:extLst>
       <p:ext uri="{BB962C8B-B14F-4D97-AF65-F5344CB8AC3E}">
@@ -9747,83 +10040,103 @@
       </p:sp>
       <p:pic>
         <p:nvPicPr>
-          <p:cNvPr id="4098" name="Picture 2">
-            <a:extLst>
-              <a:ext uri="{FF2B5EF4-FFF2-40B4-BE49-F238E27FC236}">
-                <a16:creationId xmlns:a16="http://schemas.microsoft.com/office/drawing/2014/main" id="{4BD879D4-617A-D4D1-F1DA-4118D2A9F3C1}"/>
+          <p:cNvPr id="7" name="Grafik 6" descr="Percent of 2025 CWE Top 10 KEV Weaknesses by CWE Category">
+            <a:extLst>
+              <a:ext uri="{FF2B5EF4-FFF2-40B4-BE49-F238E27FC236}">
+                <a16:creationId xmlns:a16="http://schemas.microsoft.com/office/drawing/2014/main" id="{7F8FBA32-2471-4FF9-1C08-BB15354C9106}"/>
               </a:ext>
             </a:extLst>
           </p:cNvPr>
           <p:cNvPicPr>
-            <a:picLocks noChangeAspect="1" noChangeArrowheads="1"/>
+            <a:picLocks noChangeAspect="1"/>
           </p:cNvPicPr>
           <p:nvPr/>
         </p:nvPicPr>
         <p:blipFill>
-          <a:blip r:embed="rId2">
-            <a:extLst>
-              <a:ext uri="{28A0092B-C50C-407E-A947-70E740481C1C}">
-                <a14:useLocalDpi xmlns:a14="http://schemas.microsoft.com/office/drawing/2010/main" val="0"/>
-              </a:ext>
-            </a:extLst>
-          </a:blip>
-          <a:srcRect/>
+          <a:blip r:embed="rId2"/>
           <a:stretch>
             <a:fillRect/>
           </a:stretch>
         </p:blipFill>
-        <p:spPr bwMode="auto">
-          <a:xfrm>
-            <a:off x="2561622" y="2288616"/>
-            <a:ext cx="7068755" cy="3235698"/>
+        <p:spPr>
+          <a:xfrm>
+            <a:off x="2626787" y="2251291"/>
+            <a:ext cx="6938424" cy="3072968"/>
           </a:xfrm>
           <a:prstGeom prst="rect">
             <a:avLst/>
           </a:prstGeom>
+        </p:spPr>
+      </p:pic>
+      <p:sp>
+        <p:nvSpPr>
+          <p:cNvPr id="8" name="Textfeld 7">
+            <a:extLst>
+              <a:ext uri="{FF2B5EF4-FFF2-40B4-BE49-F238E27FC236}">
+                <a16:creationId xmlns:a16="http://schemas.microsoft.com/office/drawing/2014/main" id="{C5FA8F9B-010D-DB7B-CEB1-0BDE0B858A14}"/>
+              </a:ext>
+            </a:extLst>
+          </p:cNvPr>
+          <p:cNvSpPr txBox="1"/>
+          <p:nvPr/>
+        </p:nvSpPr>
+        <p:spPr>
+          <a:xfrm>
+            <a:off x="9499235" y="5111760"/>
+            <a:ext cx="368391" cy="261610"/>
+          </a:xfrm>
+          <a:prstGeom prst="rect">
+            <a:avLst/>
+          </a:prstGeom>
           <a:noFill/>
-          <a:extLst>
-            <a:ext uri="{909E8E84-426E-40DD-AFC4-6F175D3DCCD1}">
-              <a14:hiddenFill xmlns:a14="http://schemas.microsoft.com/office/drawing/2010/main">
-                <a:solidFill>
-                  <a:srgbClr val="FFFFFF"/>
-                </a:solidFill>
-              </a14:hiddenFill>
-            </a:ext>
-          </a:extLst>
-        </p:spPr>
-      </p:pic>
-      <p:sp>
-        <p:nvSpPr>
-          <p:cNvPr id="6" name="Textfeld 5">
-            <a:extLst>
-              <a:ext uri="{FF2B5EF4-FFF2-40B4-BE49-F238E27FC236}">
-                <a16:creationId xmlns:a16="http://schemas.microsoft.com/office/drawing/2014/main" id="{BFB39912-6DE6-5953-C35D-A14BD1F08B09}"/>
-              </a:ext>
-            </a:extLst>
-          </p:cNvPr>
-          <p:cNvSpPr txBox="1"/>
-          <p:nvPr/>
-        </p:nvSpPr>
-        <p:spPr>
-          <a:xfrm>
-            <a:off x="9406939" y="5324259"/>
-            <a:ext cx="284052" cy="200055"/>
-          </a:xfrm>
-          <a:prstGeom prst="rect">
-            <a:avLst/>
-          </a:prstGeom>
-          <a:noFill/>
-        </p:spPr>
-        <p:txBody>
-          <a:bodyPr wrap="none" rtlCol="0">
+        </p:spPr>
+        <p:txBody>
+          <a:bodyPr wrap="square" rtlCol="0">
             <a:spAutoFit/>
           </a:bodyPr>
           <a:lstStyle/>
           <a:p>
             <a:r>
-              <a:rPr lang="en-US" sz="700" dirty="0"/>
-              <a:t>[3]</a:t>
-            </a:r>
+              <a:rPr lang="de-DE" sz="1100" dirty="0"/>
+              <a:t>[4]</a:t>
+            </a:r>
+            <a:endParaRPr lang="en-US" sz="1100" dirty="0"/>
+          </a:p>
+        </p:txBody>
+      </p:sp>
+      <p:sp>
+        <p:nvSpPr>
+          <p:cNvPr id="9" name="Textfeld 8">
+            <a:extLst>
+              <a:ext uri="{FF2B5EF4-FFF2-40B4-BE49-F238E27FC236}">
+                <a16:creationId xmlns:a16="http://schemas.microsoft.com/office/drawing/2014/main" id="{F4755242-601B-59F2-93E3-572516D0E314}"/>
+              </a:ext>
+            </a:extLst>
+          </p:cNvPr>
+          <p:cNvSpPr txBox="1"/>
+          <p:nvPr/>
+        </p:nvSpPr>
+        <p:spPr>
+          <a:xfrm>
+            <a:off x="1092200" y="5899150"/>
+            <a:ext cx="9642287" cy="215444"/>
+          </a:xfrm>
+          <a:prstGeom prst="rect">
+            <a:avLst/>
+          </a:prstGeom>
+          <a:noFill/>
+        </p:spPr>
+        <p:txBody>
+          <a:bodyPr wrap="square" rtlCol="0">
+            <a:spAutoFit/>
+          </a:bodyPr>
+          <a:lstStyle/>
+          <a:p>
+            <a:r>
+              <a:rPr lang="de-DE" sz="800" dirty="0"/>
+              <a:t>[4] https://cwe.mitre.org/top25/archive/2025/2025_kev_insights.html#2025_kev_pie</a:t>
+            </a:r>
+            <a:endParaRPr lang="en-US" sz="800" dirty="0"/>
           </a:p>
         </p:txBody>
       </p:sp>
@@ -10756,10 +11069,10 @@
           <p:nvPr/>
         </p:nvPicPr>
         <p:blipFill>
-          <a:blip r:embed="rId2">
+          <a:blip>
             <a:extLst>
               <a:ext uri="{96DAC541-7B7A-43D3-8B79-37D633B846F1}">
-                <asvg:svgBlip xmlns:asvg="http://schemas.microsoft.com/office/drawing/2016/SVG/main" r:embed="rId3"/>
+                <asvg:svgBlip xmlns:asvg="http://schemas.microsoft.com/office/drawing/2016/SVG/main" r:embed="rId2"/>
               </a:ext>
             </a:extLst>
           </a:blip>
@@ -10827,7 +11140,7 @@
           <p:nvPr/>
         </p:nvPicPr>
         <p:blipFill>
-          <a:blip r:embed="rId4"/>
+          <a:blip r:embed="rId3"/>
           <a:srcRect l="2885" t="4673" r="4473" b="51864"/>
           <a:stretch>
             <a:fillRect/>
@@ -11659,10 +11972,10 @@
           <p:nvPr/>
         </p:nvPicPr>
         <p:blipFill>
-          <a:blip r:embed="rId3">
+          <a:blip>
             <a:extLst>
               <a:ext uri="{96DAC541-7B7A-43D3-8B79-37D633B846F1}">
-                <asvg:svgBlip xmlns:asvg="http://schemas.microsoft.com/office/drawing/2016/SVG/main" r:embed="rId4"/>
+                <asvg:svgBlip xmlns:asvg="http://schemas.microsoft.com/office/drawing/2016/SVG/main" r:embed="rId3"/>
               </a:ext>
             </a:extLst>
           </a:blip>
@@ -12443,10 +12756,10 @@
           <p:nvPr/>
         </p:nvPicPr>
         <p:blipFill>
-          <a:blip r:embed="rId3">
+          <a:blip>
             <a:extLst>
               <a:ext uri="{96DAC541-7B7A-43D3-8B79-37D633B846F1}">
-                <asvg:svgBlip xmlns:asvg="http://schemas.microsoft.com/office/drawing/2016/SVG/main" r:embed="rId4"/>
+                <asvg:svgBlip xmlns:asvg="http://schemas.microsoft.com/office/drawing/2016/SVG/main" r:embed="rId3"/>
               </a:ext>
             </a:extLst>
           </a:blip>
@@ -13425,10 +13738,10 @@
           <p:nvPr/>
         </p:nvPicPr>
         <p:blipFill>
-          <a:blip r:embed="rId3">
+          <a:blip>
             <a:extLst>
               <a:ext uri="{96DAC541-7B7A-43D3-8B79-37D633B846F1}">
-                <asvg:svgBlip xmlns:asvg="http://schemas.microsoft.com/office/drawing/2016/SVG/main" r:embed="rId4"/>
+                <asvg:svgBlip xmlns:asvg="http://schemas.microsoft.com/office/drawing/2016/SVG/main" r:embed="rId3"/>
               </a:ext>
             </a:extLst>
           </a:blip>
@@ -13461,10 +13774,10 @@
           <p:nvPr/>
         </p:nvPicPr>
         <p:blipFill>
-          <a:blip r:embed="rId5">
+          <a:blip>
             <a:extLst>
               <a:ext uri="{96DAC541-7B7A-43D3-8B79-37D633B846F1}">
-                <asvg:svgBlip xmlns:asvg="http://schemas.microsoft.com/office/drawing/2016/SVG/main" r:embed="rId6"/>
+                <asvg:svgBlip xmlns:asvg="http://schemas.microsoft.com/office/drawing/2016/SVG/main" r:embed="rId4"/>
               </a:ext>
             </a:extLst>
           </a:blip>
@@ -13570,10 +13883,10 @@
           <p:nvPr/>
         </p:nvPicPr>
         <p:blipFill>
-          <a:blip r:embed="rId7">
+          <a:blip>
             <a:extLst>
               <a:ext uri="{96DAC541-7B7A-43D3-8B79-37D633B846F1}">
-                <asvg:svgBlip xmlns:asvg="http://schemas.microsoft.com/office/drawing/2016/SVG/main" r:embed="rId8"/>
+                <asvg:svgBlip xmlns:asvg="http://schemas.microsoft.com/office/drawing/2016/SVG/main" r:embed="rId5"/>
               </a:ext>
             </a:extLst>
           </a:blip>

</xml_diff>